<commit_message>
2/3 done w/ part 1
</commit_message>
<xml_diff>
--- a/Documentation/Final Presentation.pptx
+++ b/Documentation/Final Presentation.pptx
@@ -8,11 +8,13 @@
     <p:sldId id="256" r:id="rId2"/>
     <p:sldId id="257" r:id="rId3"/>
     <p:sldId id="262" r:id="rId4"/>
-    <p:sldId id="263" r:id="rId5"/>
-    <p:sldId id="259" r:id="rId6"/>
-    <p:sldId id="260" r:id="rId7"/>
-    <p:sldId id="264" r:id="rId8"/>
-    <p:sldId id="261" r:id="rId9"/>
+    <p:sldId id="265" r:id="rId5"/>
+    <p:sldId id="266" r:id="rId6"/>
+    <p:sldId id="263" r:id="rId7"/>
+    <p:sldId id="259" r:id="rId8"/>
+    <p:sldId id="260" r:id="rId9"/>
+    <p:sldId id="264" r:id="rId10"/>
+    <p:sldId id="261" r:id="rId11"/>
   </p:sldIdLst>
   <p:sldSz cx="12192000" cy="6858000"/>
   <p:notesSz cx="6858000" cy="9144000"/>
@@ -4842,631 +4844,7 @@
 </p:sld>
 </file>
 
-<file path=ppt/slides/slide2.xml><?xml version="1.0" encoding="utf-8"?>
-<p:sld xmlns:a="http://schemas.openxmlformats.org/drawingml/2006/main" xmlns:r="http://schemas.openxmlformats.org/officeDocument/2006/relationships" xmlns:p="http://schemas.openxmlformats.org/presentationml/2006/main">
-  <p:cSld>
-    <p:spTree>
-      <p:nvGrpSpPr>
-        <p:cNvPr id="1" name=""/>
-        <p:cNvGrpSpPr/>
-        <p:nvPr/>
-      </p:nvGrpSpPr>
-      <p:grpSpPr>
-        <a:xfrm>
-          <a:off x="0" y="0"/>
-          <a:ext cx="0" cy="0"/>
-          <a:chOff x="0" y="0"/>
-          <a:chExt cx="0" cy="0"/>
-        </a:xfrm>
-      </p:grpSpPr>
-      <p:sp>
-        <p:nvSpPr>
-          <p:cNvPr id="2" name="Title 1">
-            <a:extLst>
-              <a:ext uri="{FF2B5EF4-FFF2-40B4-BE49-F238E27FC236}">
-                <a16:creationId xmlns:a16="http://schemas.microsoft.com/office/drawing/2014/main" id="{16EDB5F4-3BF6-497A-48FF-017CB1559176}"/>
-              </a:ext>
-            </a:extLst>
-          </p:cNvPr>
-          <p:cNvSpPr>
-            <a:spLocks noGrp="1"/>
-          </p:cNvSpPr>
-          <p:nvPr>
-            <p:ph type="title"/>
-          </p:nvPr>
-        </p:nvSpPr>
-        <p:spPr/>
-        <p:txBody>
-          <a:bodyPr/>
-          <a:lstStyle/>
-          <a:p>
-            <a:r>
-              <a:rPr lang="en-US" dirty="0"/>
-              <a:t>Part 1 – Approach </a:t>
-            </a:r>
-          </a:p>
-        </p:txBody>
-      </p:sp>
-      <p:sp>
-        <p:nvSpPr>
-          <p:cNvPr id="3" name="Content Placeholder 2">
-            <a:extLst>
-              <a:ext uri="{FF2B5EF4-FFF2-40B4-BE49-F238E27FC236}">
-                <a16:creationId xmlns:a16="http://schemas.microsoft.com/office/drawing/2014/main" id="{901B5B7B-EE18-EB6F-E7AD-6D5F1DEC6953}"/>
-              </a:ext>
-            </a:extLst>
-          </p:cNvPr>
-          <p:cNvSpPr>
-            <a:spLocks noGrp="1"/>
-          </p:cNvSpPr>
-          <p:nvPr>
-            <p:ph idx="1"/>
-          </p:nvPr>
-        </p:nvSpPr>
-        <p:spPr/>
-        <p:txBody>
-          <a:bodyPr/>
-          <a:lstStyle/>
-          <a:p>
-            <a:endParaRPr lang="en-US" dirty="0"/>
-          </a:p>
-        </p:txBody>
-      </p:sp>
-    </p:spTree>
-    <p:extLst>
-      <p:ext uri="{BB962C8B-B14F-4D97-AF65-F5344CB8AC3E}">
-        <p14:creationId xmlns:p14="http://schemas.microsoft.com/office/powerpoint/2010/main" val="3583789835"/>
-      </p:ext>
-    </p:extLst>
-  </p:cSld>
-  <p:clrMapOvr>
-    <a:masterClrMapping/>
-  </p:clrMapOvr>
-</p:sld>
-</file>
-
-<file path=ppt/slides/slide3.xml><?xml version="1.0" encoding="utf-8"?>
-<p:sld xmlns:a="http://schemas.openxmlformats.org/drawingml/2006/main" xmlns:r="http://schemas.openxmlformats.org/officeDocument/2006/relationships" xmlns:p="http://schemas.openxmlformats.org/presentationml/2006/main">
-  <p:cSld>
-    <p:spTree>
-      <p:nvGrpSpPr>
-        <p:cNvPr id="1" name=""/>
-        <p:cNvGrpSpPr/>
-        <p:nvPr/>
-      </p:nvGrpSpPr>
-      <p:grpSpPr>
-        <a:xfrm>
-          <a:off x="0" y="0"/>
-          <a:ext cx="0" cy="0"/>
-          <a:chOff x="0" y="0"/>
-          <a:chExt cx="0" cy="0"/>
-        </a:xfrm>
-      </p:grpSpPr>
-      <p:sp>
-        <p:nvSpPr>
-          <p:cNvPr id="2" name="Title 1">
-            <a:extLst>
-              <a:ext uri="{FF2B5EF4-FFF2-40B4-BE49-F238E27FC236}">
-                <a16:creationId xmlns:a16="http://schemas.microsoft.com/office/drawing/2014/main" id="{BECEAD95-E2F3-1454-3809-832098E09252}"/>
-              </a:ext>
-            </a:extLst>
-          </p:cNvPr>
-          <p:cNvSpPr>
-            <a:spLocks noGrp="1"/>
-          </p:cNvSpPr>
-          <p:nvPr>
-            <p:ph type="title"/>
-          </p:nvPr>
-        </p:nvSpPr>
-        <p:spPr/>
-        <p:txBody>
-          <a:bodyPr/>
-          <a:lstStyle/>
-          <a:p>
-            <a:r>
-              <a:rPr lang="en-US" dirty="0"/>
-              <a:t>Part 1 – Results</a:t>
-            </a:r>
-          </a:p>
-        </p:txBody>
-      </p:sp>
-      <p:sp>
-        <p:nvSpPr>
-          <p:cNvPr id="3" name="Content Placeholder 2">
-            <a:extLst>
-              <a:ext uri="{FF2B5EF4-FFF2-40B4-BE49-F238E27FC236}">
-                <a16:creationId xmlns:a16="http://schemas.microsoft.com/office/drawing/2014/main" id="{9977B685-5EAF-7CEA-BF76-3B9365AED698}"/>
-              </a:ext>
-            </a:extLst>
-          </p:cNvPr>
-          <p:cNvSpPr>
-            <a:spLocks noGrp="1"/>
-          </p:cNvSpPr>
-          <p:nvPr>
-            <p:ph idx="1"/>
-          </p:nvPr>
-        </p:nvSpPr>
-        <p:spPr/>
-        <p:txBody>
-          <a:bodyPr/>
-          <a:lstStyle/>
-          <a:p>
-            <a:endParaRPr lang="en-US"/>
-          </a:p>
-        </p:txBody>
-      </p:sp>
-    </p:spTree>
-    <p:extLst>
-      <p:ext uri="{BB962C8B-B14F-4D97-AF65-F5344CB8AC3E}">
-        <p14:creationId xmlns:p14="http://schemas.microsoft.com/office/powerpoint/2010/main" val="700886777"/>
-      </p:ext>
-    </p:extLst>
-  </p:cSld>
-  <p:clrMapOvr>
-    <a:masterClrMapping/>
-  </p:clrMapOvr>
-</p:sld>
-</file>
-
-<file path=ppt/slides/slide4.xml><?xml version="1.0" encoding="utf-8"?>
-<p:sld xmlns:a="http://schemas.openxmlformats.org/drawingml/2006/main" xmlns:r="http://schemas.openxmlformats.org/officeDocument/2006/relationships" xmlns:p="http://schemas.openxmlformats.org/presentationml/2006/main">
-  <p:cSld>
-    <p:spTree>
-      <p:nvGrpSpPr>
-        <p:cNvPr id="1" name=""/>
-        <p:cNvGrpSpPr/>
-        <p:nvPr/>
-      </p:nvGrpSpPr>
-      <p:grpSpPr>
-        <a:xfrm>
-          <a:off x="0" y="0"/>
-          <a:ext cx="0" cy="0"/>
-          <a:chOff x="0" y="0"/>
-          <a:chExt cx="0" cy="0"/>
-        </a:xfrm>
-      </p:grpSpPr>
-      <p:sp>
-        <p:nvSpPr>
-          <p:cNvPr id="2" name="Title 1">
-            <a:extLst>
-              <a:ext uri="{FF2B5EF4-FFF2-40B4-BE49-F238E27FC236}">
-                <a16:creationId xmlns:a16="http://schemas.microsoft.com/office/drawing/2014/main" id="{ED040810-D060-8C4E-8BAA-E64C6833A0AB}"/>
-              </a:ext>
-            </a:extLst>
-          </p:cNvPr>
-          <p:cNvSpPr>
-            <a:spLocks noGrp="1"/>
-          </p:cNvSpPr>
-          <p:nvPr>
-            <p:ph type="title"/>
-          </p:nvPr>
-        </p:nvSpPr>
-        <p:spPr/>
-        <p:txBody>
-          <a:bodyPr/>
-          <a:lstStyle/>
-          <a:p>
-            <a:r>
-              <a:rPr lang="en-US" dirty="0"/>
-              <a:t>Part 1 – Conclusion</a:t>
-            </a:r>
-          </a:p>
-        </p:txBody>
-      </p:sp>
-      <p:sp>
-        <p:nvSpPr>
-          <p:cNvPr id="3" name="Content Placeholder 2">
-            <a:extLst>
-              <a:ext uri="{FF2B5EF4-FFF2-40B4-BE49-F238E27FC236}">
-                <a16:creationId xmlns:a16="http://schemas.microsoft.com/office/drawing/2014/main" id="{1A3E2549-1EBC-B27D-5B4C-56123FFE165B}"/>
-              </a:ext>
-            </a:extLst>
-          </p:cNvPr>
-          <p:cNvSpPr>
-            <a:spLocks noGrp="1"/>
-          </p:cNvSpPr>
-          <p:nvPr>
-            <p:ph idx="1"/>
-          </p:nvPr>
-        </p:nvSpPr>
-        <p:spPr/>
-        <p:txBody>
-          <a:bodyPr/>
-          <a:lstStyle/>
-          <a:p>
-            <a:endParaRPr lang="en-US"/>
-          </a:p>
-        </p:txBody>
-      </p:sp>
-    </p:spTree>
-    <p:extLst>
-      <p:ext uri="{BB962C8B-B14F-4D97-AF65-F5344CB8AC3E}">
-        <p14:creationId xmlns:p14="http://schemas.microsoft.com/office/powerpoint/2010/main" val="2822892622"/>
-      </p:ext>
-    </p:extLst>
-  </p:cSld>
-  <p:clrMapOvr>
-    <a:masterClrMapping/>
-  </p:clrMapOvr>
-</p:sld>
-</file>
-
-<file path=ppt/slides/slide5.xml><?xml version="1.0" encoding="utf-8"?>
-<p:sld xmlns:a="http://schemas.openxmlformats.org/drawingml/2006/main" xmlns:r="http://schemas.openxmlformats.org/officeDocument/2006/relationships" xmlns:p="http://schemas.openxmlformats.org/presentationml/2006/main">
-  <p:cSld>
-    <p:spTree>
-      <p:nvGrpSpPr>
-        <p:cNvPr id="1" name=""/>
-        <p:cNvGrpSpPr/>
-        <p:nvPr/>
-      </p:nvGrpSpPr>
-      <p:grpSpPr>
-        <a:xfrm>
-          <a:off x="0" y="0"/>
-          <a:ext cx="0" cy="0"/>
-          <a:chOff x="0" y="0"/>
-          <a:chExt cx="0" cy="0"/>
-        </a:xfrm>
-      </p:grpSpPr>
-      <p:sp>
-        <p:nvSpPr>
-          <p:cNvPr id="2" name="Title 1">
-            <a:extLst>
-              <a:ext uri="{FF2B5EF4-FFF2-40B4-BE49-F238E27FC236}">
-                <a16:creationId xmlns:a16="http://schemas.microsoft.com/office/drawing/2014/main" id="{68F4FC0C-A23E-D74B-F1DF-5D461D21668D}"/>
-              </a:ext>
-            </a:extLst>
-          </p:cNvPr>
-          <p:cNvSpPr>
-            <a:spLocks noGrp="1"/>
-          </p:cNvSpPr>
-          <p:nvPr>
-            <p:ph type="title"/>
-          </p:nvPr>
-        </p:nvSpPr>
-        <p:spPr/>
-        <p:txBody>
-          <a:bodyPr/>
-          <a:lstStyle/>
-          <a:p>
-            <a:r>
-              <a:rPr lang="en-US" dirty="0"/>
-              <a:t>Part 2 – Approach</a:t>
-            </a:r>
-          </a:p>
-        </p:txBody>
-      </p:sp>
-      <p:sp>
-        <p:nvSpPr>
-          <p:cNvPr id="3" name="Content Placeholder 2">
-            <a:extLst>
-              <a:ext uri="{FF2B5EF4-FFF2-40B4-BE49-F238E27FC236}">
-                <a16:creationId xmlns:a16="http://schemas.microsoft.com/office/drawing/2014/main" id="{585BBA4F-AC3D-AC68-6162-E0F999A8794B}"/>
-              </a:ext>
-            </a:extLst>
-          </p:cNvPr>
-          <p:cNvSpPr>
-            <a:spLocks noGrp="1"/>
-          </p:cNvSpPr>
-          <p:nvPr>
-            <p:ph idx="1"/>
-          </p:nvPr>
-        </p:nvSpPr>
-        <p:spPr/>
-        <p:txBody>
-          <a:bodyPr>
-            <a:normAutofit fontScale="92500" lnSpcReduction="20000"/>
-          </a:bodyPr>
-          <a:lstStyle/>
-          <a:p>
-            <a:r>
-              <a:rPr lang="en-US" dirty="0"/>
-              <a:t>Model Selection (Traditional): </a:t>
-            </a:r>
-            <a:r>
-              <a:rPr lang="en-US" dirty="0" err="1"/>
-              <a:t>LogReg</a:t>
-            </a:r>
-            <a:endParaRPr lang="en-US" dirty="0"/>
-          </a:p>
-          <a:p>
-            <a:pPr lvl="1"/>
-            <a:r>
-              <a:rPr lang="en-US" dirty="0" err="1"/>
-              <a:t>StratifiedKFold</a:t>
-            </a:r>
-            <a:r>
-              <a:rPr lang="en-US" dirty="0"/>
-              <a:t> CV used to determine best model</a:t>
-            </a:r>
-          </a:p>
-          <a:p>
-            <a:pPr lvl="1"/>
-            <a:r>
-              <a:rPr lang="en-US" dirty="0" err="1"/>
-              <a:t>StandardScalar</a:t>
-            </a:r>
-            <a:r>
-              <a:rPr lang="en-US" dirty="0"/>
-              <a:t> used to normalize data</a:t>
-            </a:r>
-          </a:p>
-          <a:p>
-            <a:pPr lvl="1"/>
-            <a:r>
-              <a:rPr lang="en-US" dirty="0" err="1"/>
-              <a:t>SelectKBest</a:t>
-            </a:r>
-            <a:r>
-              <a:rPr lang="en-US" dirty="0"/>
-              <a:t> used to reduce dimensionality</a:t>
-            </a:r>
-          </a:p>
-          <a:p>
-            <a:pPr lvl="1"/>
-            <a:endParaRPr lang="en-US" dirty="0"/>
-          </a:p>
-          <a:p>
-            <a:r>
-              <a:rPr lang="en-US" dirty="0"/>
-              <a:t>Model Selection (Deep Learning): MLP</a:t>
-            </a:r>
-          </a:p>
-          <a:p>
-            <a:pPr lvl="1"/>
-            <a:r>
-              <a:rPr lang="en-US" dirty="0" err="1"/>
-              <a:t>RepeatedStratifiedKFold</a:t>
-            </a:r>
-            <a:r>
-              <a:rPr lang="en-US" dirty="0"/>
-              <a:t> CV used to determine hyperparameters</a:t>
-            </a:r>
-          </a:p>
-          <a:p>
-            <a:pPr lvl="1"/>
-            <a:r>
-              <a:rPr lang="en-US" dirty="0" err="1"/>
-              <a:t>StandardScalar</a:t>
-            </a:r>
-            <a:r>
-              <a:rPr lang="en-US" dirty="0"/>
-              <a:t> used to normalize data</a:t>
-            </a:r>
-          </a:p>
-          <a:p>
-            <a:pPr lvl="1"/>
-            <a:r>
-              <a:rPr lang="en-US" dirty="0" err="1"/>
-              <a:t>SelectKBest</a:t>
-            </a:r>
-            <a:r>
-              <a:rPr lang="en-US" dirty="0"/>
-              <a:t> used to reduce dimensionality</a:t>
-            </a:r>
-          </a:p>
-          <a:p>
-            <a:pPr lvl="1"/>
-            <a:r>
-              <a:rPr lang="en-US" dirty="0" err="1"/>
-              <a:t>ReLU</a:t>
-            </a:r>
-            <a:r>
-              <a:rPr lang="en-US" dirty="0"/>
-              <a:t> with 0.25 dropout</a:t>
-            </a:r>
-          </a:p>
-          <a:p>
-            <a:pPr lvl="1"/>
-            <a:r>
-              <a:rPr lang="en-US" dirty="0" err="1"/>
-              <a:t>BatchNorm</a:t>
-            </a:r>
-            <a:r>
-              <a:rPr lang="en-US" dirty="0"/>
-              <a:t> used to normalize activations</a:t>
-            </a:r>
-          </a:p>
-          <a:p>
-            <a:pPr lvl="1"/>
-            <a:r>
-              <a:rPr lang="en-US" dirty="0" err="1"/>
-              <a:t>BCEWithLogitsLoss</a:t>
-            </a:r>
-            <a:r>
-              <a:rPr lang="en-US" dirty="0"/>
-              <a:t> used to measure error</a:t>
-            </a:r>
-          </a:p>
-          <a:p>
-            <a:endParaRPr lang="en-US" dirty="0"/>
-          </a:p>
-        </p:txBody>
-      </p:sp>
-    </p:spTree>
-    <p:extLst>
-      <p:ext uri="{BB962C8B-B14F-4D97-AF65-F5344CB8AC3E}">
-        <p14:creationId xmlns:p14="http://schemas.microsoft.com/office/powerpoint/2010/main" val="185969209"/>
-      </p:ext>
-    </p:extLst>
-  </p:cSld>
-  <p:clrMapOvr>
-    <a:masterClrMapping/>
-  </p:clrMapOvr>
-</p:sld>
-</file>
-
-<file path=ppt/slides/slide6.xml><?xml version="1.0" encoding="utf-8"?>
-<p:sld xmlns:a="http://schemas.openxmlformats.org/drawingml/2006/main" xmlns:r="http://schemas.openxmlformats.org/officeDocument/2006/relationships" xmlns:p="http://schemas.openxmlformats.org/presentationml/2006/main">
-  <p:cSld>
-    <p:spTree>
-      <p:nvGrpSpPr>
-        <p:cNvPr id="1" name=""/>
-        <p:cNvGrpSpPr/>
-        <p:nvPr/>
-      </p:nvGrpSpPr>
-      <p:grpSpPr>
-        <a:xfrm>
-          <a:off x="0" y="0"/>
-          <a:ext cx="0" cy="0"/>
-          <a:chOff x="0" y="0"/>
-          <a:chExt cx="0" cy="0"/>
-        </a:xfrm>
-      </p:grpSpPr>
-      <p:sp>
-        <p:nvSpPr>
-          <p:cNvPr id="2" name="Title 1">
-            <a:extLst>
-              <a:ext uri="{FF2B5EF4-FFF2-40B4-BE49-F238E27FC236}">
-                <a16:creationId xmlns:a16="http://schemas.microsoft.com/office/drawing/2014/main" id="{64AD0586-234F-A455-C049-C953A2065E61}"/>
-              </a:ext>
-            </a:extLst>
-          </p:cNvPr>
-          <p:cNvSpPr>
-            <a:spLocks noGrp="1"/>
-          </p:cNvSpPr>
-          <p:nvPr>
-            <p:ph type="title"/>
-          </p:nvPr>
-        </p:nvSpPr>
-        <p:spPr/>
-        <p:txBody>
-          <a:bodyPr/>
-          <a:lstStyle/>
-          <a:p>
-            <a:r>
-              <a:rPr lang="en-US" dirty="0"/>
-              <a:t>Part 2 – Results</a:t>
-            </a:r>
-          </a:p>
-        </p:txBody>
-      </p:sp>
-      <p:sp>
-        <p:nvSpPr>
-          <p:cNvPr id="3" name="Content Placeholder 2">
-            <a:extLst>
-              <a:ext uri="{FF2B5EF4-FFF2-40B4-BE49-F238E27FC236}">
-                <a16:creationId xmlns:a16="http://schemas.microsoft.com/office/drawing/2014/main" id="{561478C8-F244-57BA-FCE1-BB7325332BFE}"/>
-              </a:ext>
-            </a:extLst>
-          </p:cNvPr>
-          <p:cNvSpPr>
-            <a:spLocks noGrp="1"/>
-          </p:cNvSpPr>
-          <p:nvPr>
-            <p:ph idx="1"/>
-          </p:nvPr>
-        </p:nvSpPr>
-        <p:spPr/>
-        <p:txBody>
-          <a:bodyPr/>
-          <a:lstStyle/>
-          <a:p>
-            <a:endParaRPr lang="en-US" dirty="0"/>
-          </a:p>
-        </p:txBody>
-      </p:sp>
-    </p:spTree>
-    <p:extLst>
-      <p:ext uri="{BB962C8B-B14F-4D97-AF65-F5344CB8AC3E}">
-        <p14:creationId xmlns:p14="http://schemas.microsoft.com/office/powerpoint/2010/main" val="373993910"/>
-      </p:ext>
-    </p:extLst>
-  </p:cSld>
-  <p:clrMapOvr>
-    <a:masterClrMapping/>
-  </p:clrMapOvr>
-</p:sld>
-</file>
-
-<file path=ppt/slides/slide7.xml><?xml version="1.0" encoding="utf-8"?>
-<p:sld xmlns:a="http://schemas.openxmlformats.org/drawingml/2006/main" xmlns:r="http://schemas.openxmlformats.org/officeDocument/2006/relationships" xmlns:p="http://schemas.openxmlformats.org/presentationml/2006/main">
-  <p:cSld>
-    <p:spTree>
-      <p:nvGrpSpPr>
-        <p:cNvPr id="1" name=""/>
-        <p:cNvGrpSpPr/>
-        <p:nvPr/>
-      </p:nvGrpSpPr>
-      <p:grpSpPr>
-        <a:xfrm>
-          <a:off x="0" y="0"/>
-          <a:ext cx="0" cy="0"/>
-          <a:chOff x="0" y="0"/>
-          <a:chExt cx="0" cy="0"/>
-        </a:xfrm>
-      </p:grpSpPr>
-      <p:sp>
-        <p:nvSpPr>
-          <p:cNvPr id="2" name="Title 1">
-            <a:extLst>
-              <a:ext uri="{FF2B5EF4-FFF2-40B4-BE49-F238E27FC236}">
-                <a16:creationId xmlns:a16="http://schemas.microsoft.com/office/drawing/2014/main" id="{804B22E2-45CD-80E4-43BD-6E3DC616A6BA}"/>
-              </a:ext>
-            </a:extLst>
-          </p:cNvPr>
-          <p:cNvSpPr>
-            <a:spLocks noGrp="1"/>
-          </p:cNvSpPr>
-          <p:nvPr>
-            <p:ph type="title"/>
-          </p:nvPr>
-        </p:nvSpPr>
-        <p:spPr/>
-        <p:txBody>
-          <a:bodyPr/>
-          <a:lstStyle/>
-          <a:p>
-            <a:r>
-              <a:rPr lang="en-US" dirty="0"/>
-              <a:t>Part </a:t>
-            </a:r>
-            <a:r>
-              <a:rPr lang="en-US"/>
-              <a:t>2 – Conclusion</a:t>
-            </a:r>
-          </a:p>
-        </p:txBody>
-      </p:sp>
-      <p:sp>
-        <p:nvSpPr>
-          <p:cNvPr id="3" name="Content Placeholder 2">
-            <a:extLst>
-              <a:ext uri="{FF2B5EF4-FFF2-40B4-BE49-F238E27FC236}">
-                <a16:creationId xmlns:a16="http://schemas.microsoft.com/office/drawing/2014/main" id="{9A469714-4927-D2FD-DF64-9AC206900752}"/>
-              </a:ext>
-            </a:extLst>
-          </p:cNvPr>
-          <p:cNvSpPr>
-            <a:spLocks noGrp="1"/>
-          </p:cNvSpPr>
-          <p:nvPr>
-            <p:ph idx="1"/>
-          </p:nvPr>
-        </p:nvSpPr>
-        <p:spPr/>
-        <p:txBody>
-          <a:bodyPr/>
-          <a:lstStyle/>
-          <a:p>
-            <a:endParaRPr lang="en-US"/>
-          </a:p>
-        </p:txBody>
-      </p:sp>
-    </p:spTree>
-    <p:extLst>
-      <p:ext uri="{BB962C8B-B14F-4D97-AF65-F5344CB8AC3E}">
-        <p14:creationId xmlns:p14="http://schemas.microsoft.com/office/powerpoint/2010/main" val="1077775097"/>
-      </p:ext>
-    </p:extLst>
-  </p:cSld>
-  <p:clrMapOvr>
-    <a:masterClrMapping/>
-  </p:clrMapOvr>
-</p:sld>
-</file>
-
-<file path=ppt/slides/slide8.xml><?xml version="1.0" encoding="utf-8"?>
+<file path=ppt/slides/slide10.xml><?xml version="1.0" encoding="utf-8"?>
 <p:sld xmlns:a="http://schemas.openxmlformats.org/drawingml/2006/main" xmlns:r="http://schemas.openxmlformats.org/officeDocument/2006/relationships" xmlns:p="http://schemas.openxmlformats.org/presentationml/2006/main">
   <p:cSld>
     <p:bg>
@@ -6671,6 +6049,966 @@
     <p:extLst>
       <p:ext uri="{BB962C8B-B14F-4D97-AF65-F5344CB8AC3E}">
         <p14:creationId xmlns:p14="http://schemas.microsoft.com/office/powerpoint/2010/main" val="1840442817"/>
+      </p:ext>
+    </p:extLst>
+  </p:cSld>
+  <p:clrMapOvr>
+    <a:masterClrMapping/>
+  </p:clrMapOvr>
+</p:sld>
+</file>
+
+<file path=ppt/slides/slide2.xml><?xml version="1.0" encoding="utf-8"?>
+<p:sld xmlns:a="http://schemas.openxmlformats.org/drawingml/2006/main" xmlns:r="http://schemas.openxmlformats.org/officeDocument/2006/relationships" xmlns:p="http://schemas.openxmlformats.org/presentationml/2006/main">
+  <p:cSld>
+    <p:spTree>
+      <p:nvGrpSpPr>
+        <p:cNvPr id="1" name=""/>
+        <p:cNvGrpSpPr/>
+        <p:nvPr/>
+      </p:nvGrpSpPr>
+      <p:grpSpPr>
+        <a:xfrm>
+          <a:off x="0" y="0"/>
+          <a:ext cx="0" cy="0"/>
+          <a:chOff x="0" y="0"/>
+          <a:chExt cx="0" cy="0"/>
+        </a:xfrm>
+      </p:grpSpPr>
+      <p:sp>
+        <p:nvSpPr>
+          <p:cNvPr id="2" name="Title 1">
+            <a:extLst>
+              <a:ext uri="{FF2B5EF4-FFF2-40B4-BE49-F238E27FC236}">
+                <a16:creationId xmlns:a16="http://schemas.microsoft.com/office/drawing/2014/main" id="{16EDB5F4-3BF6-497A-48FF-017CB1559176}"/>
+              </a:ext>
+            </a:extLst>
+          </p:cNvPr>
+          <p:cNvSpPr>
+            <a:spLocks noGrp="1"/>
+          </p:cNvSpPr>
+          <p:nvPr>
+            <p:ph type="title"/>
+          </p:nvPr>
+        </p:nvSpPr>
+        <p:spPr/>
+        <p:txBody>
+          <a:bodyPr/>
+          <a:lstStyle/>
+          <a:p>
+            <a:r>
+              <a:rPr lang="en-US" dirty="0"/>
+              <a:t>Part 1a - Approach </a:t>
+            </a:r>
+          </a:p>
+        </p:txBody>
+      </p:sp>
+      <p:sp>
+        <p:nvSpPr>
+          <p:cNvPr id="3" name="Content Placeholder 2">
+            <a:extLst>
+              <a:ext uri="{FF2B5EF4-FFF2-40B4-BE49-F238E27FC236}">
+                <a16:creationId xmlns:a16="http://schemas.microsoft.com/office/drawing/2014/main" id="{901B5B7B-EE18-EB6F-E7AD-6D5F1DEC6953}"/>
+              </a:ext>
+            </a:extLst>
+          </p:cNvPr>
+          <p:cNvSpPr>
+            <a:spLocks noGrp="1"/>
+          </p:cNvSpPr>
+          <p:nvPr>
+            <p:ph idx="1"/>
+          </p:nvPr>
+        </p:nvSpPr>
+        <p:spPr/>
+        <p:txBody>
+          <a:bodyPr/>
+          <a:lstStyle/>
+          <a:p>
+            <a:r>
+              <a:rPr lang="en-US" dirty="0"/>
+              <a:t>Model Section (Traditional): Gradient Boosting + PCA</a:t>
+            </a:r>
+          </a:p>
+          <a:p>
+            <a:pPr lvl="1"/>
+            <a:r>
+              <a:rPr lang="en-US" dirty="0" err="1"/>
+              <a:t>StratifiedKFold</a:t>
+            </a:r>
+            <a:r>
+              <a:rPr lang="en-US" dirty="0"/>
+              <a:t> CV (k=5) used to test multiple models</a:t>
+            </a:r>
+          </a:p>
+          <a:p>
+            <a:pPr lvl="2"/>
+            <a:r>
+              <a:rPr lang="en-US" dirty="0"/>
+              <a:t>Logistic Regression, KNN, SVM...</a:t>
+            </a:r>
+          </a:p>
+          <a:p>
+            <a:pPr lvl="2"/>
+            <a:r>
+              <a:rPr lang="en-US" dirty="0"/>
+              <a:t>Performance metric was accuracy over all 5 folds</a:t>
+            </a:r>
+          </a:p>
+          <a:p>
+            <a:pPr lvl="3"/>
+            <a:r>
+              <a:rPr lang="en-US" dirty="0"/>
+              <a:t>Perfectly balanced classes</a:t>
+            </a:r>
+            <a:endParaRPr lang="en-US" b="1" dirty="0"/>
+          </a:p>
+          <a:p>
+            <a:pPr lvl="1"/>
+            <a:r>
+              <a:rPr lang="en-US" dirty="0"/>
+              <a:t>PCA to reduce dimensionality</a:t>
+            </a:r>
+          </a:p>
+          <a:p>
+            <a:pPr lvl="2"/>
+            <a:r>
+              <a:rPr lang="en-US" dirty="0"/>
+              <a:t>48 dimensions to 31 dimensions</a:t>
+            </a:r>
+          </a:p>
+          <a:p>
+            <a:pPr lvl="2"/>
+            <a:r>
+              <a:rPr lang="en-US" dirty="0"/>
+              <a:t>95% variance threshold</a:t>
+            </a:r>
+          </a:p>
+          <a:p>
+            <a:pPr lvl="1"/>
+            <a:r>
+              <a:rPr lang="en-US" dirty="0" err="1"/>
+              <a:t>Standardscalar</a:t>
+            </a:r>
+            <a:r>
+              <a:rPr lang="en-US" dirty="0"/>
+              <a:t> to normalize data</a:t>
+            </a:r>
+          </a:p>
+          <a:p>
+            <a:pPr lvl="1"/>
+            <a:r>
+              <a:rPr lang="en-US" dirty="0"/>
+              <a:t>Used </a:t>
+            </a:r>
+            <a:r>
+              <a:rPr lang="en-US" dirty="0" err="1"/>
+              <a:t>GirdSearchCV</a:t>
+            </a:r>
+            <a:r>
+              <a:rPr lang="en-US" dirty="0"/>
+              <a:t> for some models</a:t>
+            </a:r>
+          </a:p>
+        </p:txBody>
+      </p:sp>
+    </p:spTree>
+    <p:extLst>
+      <p:ext uri="{BB962C8B-B14F-4D97-AF65-F5344CB8AC3E}">
+        <p14:creationId xmlns:p14="http://schemas.microsoft.com/office/powerpoint/2010/main" val="3583789835"/>
+      </p:ext>
+    </p:extLst>
+  </p:cSld>
+  <p:clrMapOvr>
+    <a:masterClrMapping/>
+  </p:clrMapOvr>
+</p:sld>
+</file>
+
+<file path=ppt/slides/slide3.xml><?xml version="1.0" encoding="utf-8"?>
+<p:sld xmlns:a="http://schemas.openxmlformats.org/drawingml/2006/main" xmlns:r="http://schemas.openxmlformats.org/officeDocument/2006/relationships" xmlns:p="http://schemas.openxmlformats.org/presentationml/2006/main">
+  <p:cSld>
+    <p:spTree>
+      <p:nvGrpSpPr>
+        <p:cNvPr id="1" name=""/>
+        <p:cNvGrpSpPr/>
+        <p:nvPr/>
+      </p:nvGrpSpPr>
+      <p:grpSpPr>
+        <a:xfrm>
+          <a:off x="0" y="0"/>
+          <a:ext cx="0" cy="0"/>
+          <a:chOff x="0" y="0"/>
+          <a:chExt cx="0" cy="0"/>
+        </a:xfrm>
+      </p:grpSpPr>
+      <p:sp>
+        <p:nvSpPr>
+          <p:cNvPr id="2" name="Title 1">
+            <a:extLst>
+              <a:ext uri="{FF2B5EF4-FFF2-40B4-BE49-F238E27FC236}">
+                <a16:creationId xmlns:a16="http://schemas.microsoft.com/office/drawing/2014/main" id="{BECEAD95-E2F3-1454-3809-832098E09252}"/>
+              </a:ext>
+            </a:extLst>
+          </p:cNvPr>
+          <p:cNvSpPr>
+            <a:spLocks noGrp="1"/>
+          </p:cNvSpPr>
+          <p:nvPr>
+            <p:ph type="title"/>
+          </p:nvPr>
+        </p:nvSpPr>
+        <p:spPr/>
+        <p:txBody>
+          <a:bodyPr/>
+          <a:lstStyle/>
+          <a:p>
+            <a:r>
+              <a:rPr lang="en-US" dirty="0"/>
+              <a:t>Part 1a - Results</a:t>
+            </a:r>
+          </a:p>
+        </p:txBody>
+      </p:sp>
+      <p:sp>
+        <p:nvSpPr>
+          <p:cNvPr id="3" name="Content Placeholder 2">
+            <a:extLst>
+              <a:ext uri="{FF2B5EF4-FFF2-40B4-BE49-F238E27FC236}">
+                <a16:creationId xmlns:a16="http://schemas.microsoft.com/office/drawing/2014/main" id="{9977B685-5EAF-7CEA-BF76-3B9365AED698}"/>
+              </a:ext>
+            </a:extLst>
+          </p:cNvPr>
+          <p:cNvSpPr>
+            <a:spLocks noGrp="1"/>
+          </p:cNvSpPr>
+          <p:nvPr>
+            <p:ph idx="1"/>
+          </p:nvPr>
+        </p:nvSpPr>
+        <p:spPr/>
+        <p:txBody>
+          <a:bodyPr/>
+          <a:lstStyle/>
+          <a:p>
+            <a:r>
+              <a:rPr lang="en-US" dirty="0"/>
+              <a:t>Five-fold CV results (80%)</a:t>
+            </a:r>
+          </a:p>
+          <a:p>
+            <a:pPr lvl="1"/>
+            <a:r>
+              <a:rPr lang="en-US" dirty="0"/>
+              <a:t>Mean accuracy of 0.759</a:t>
+            </a:r>
+          </a:p>
+          <a:p>
+            <a:pPr lvl="1"/>
+            <a:r>
+              <a:rPr lang="en-US" dirty="0"/>
+              <a:t>Mean F1 score of 0.758</a:t>
+            </a:r>
+          </a:p>
+          <a:p>
+            <a:r>
+              <a:rPr lang="en-US" dirty="0"/>
+              <a:t>20% held out set</a:t>
+            </a:r>
+          </a:p>
+          <a:p>
+            <a:pPr lvl="1"/>
+            <a:r>
+              <a:rPr lang="en-US" dirty="0"/>
+              <a:t>Mean accuracy and F1 score of 0.760</a:t>
+            </a:r>
+          </a:p>
+          <a:p>
+            <a:r>
+              <a:rPr lang="en-US" dirty="0"/>
+              <a:t>Predicted Results on test set</a:t>
+            </a:r>
+          </a:p>
+          <a:p>
+            <a:pPr lvl="1"/>
+            <a:r>
+              <a:rPr lang="en-US" dirty="0"/>
+              <a:t>Similar to held out set</a:t>
+            </a:r>
+          </a:p>
+        </p:txBody>
+      </p:sp>
+    </p:spTree>
+    <p:extLst>
+      <p:ext uri="{BB962C8B-B14F-4D97-AF65-F5344CB8AC3E}">
+        <p14:creationId xmlns:p14="http://schemas.microsoft.com/office/powerpoint/2010/main" val="700886777"/>
+      </p:ext>
+    </p:extLst>
+  </p:cSld>
+  <p:clrMapOvr>
+    <a:masterClrMapping/>
+  </p:clrMapOvr>
+</p:sld>
+</file>
+
+<file path=ppt/slides/slide4.xml><?xml version="1.0" encoding="utf-8"?>
+<p:sld xmlns:a="http://schemas.openxmlformats.org/drawingml/2006/main" xmlns:r="http://schemas.openxmlformats.org/officeDocument/2006/relationships" xmlns:p="http://schemas.openxmlformats.org/presentationml/2006/main">
+  <p:cSld>
+    <p:spTree>
+      <p:nvGrpSpPr>
+        <p:cNvPr id="1" name=""/>
+        <p:cNvGrpSpPr/>
+        <p:nvPr/>
+      </p:nvGrpSpPr>
+      <p:grpSpPr>
+        <a:xfrm>
+          <a:off x="0" y="0"/>
+          <a:ext cx="0" cy="0"/>
+          <a:chOff x="0" y="0"/>
+          <a:chExt cx="0" cy="0"/>
+        </a:xfrm>
+      </p:grpSpPr>
+      <p:sp>
+        <p:nvSpPr>
+          <p:cNvPr id="2" name="Title 1">
+            <a:extLst>
+              <a:ext uri="{FF2B5EF4-FFF2-40B4-BE49-F238E27FC236}">
+                <a16:creationId xmlns:a16="http://schemas.microsoft.com/office/drawing/2014/main" id="{9C754F3D-4067-E7D6-865F-49FF49C1EB96}"/>
+              </a:ext>
+            </a:extLst>
+          </p:cNvPr>
+          <p:cNvSpPr>
+            <a:spLocks noGrp="1"/>
+          </p:cNvSpPr>
+          <p:nvPr>
+            <p:ph type="title"/>
+          </p:nvPr>
+        </p:nvSpPr>
+        <p:spPr/>
+        <p:txBody>
+          <a:bodyPr/>
+          <a:lstStyle/>
+          <a:p>
+            <a:r>
+              <a:rPr lang="en-US" dirty="0"/>
+              <a:t>Part 1b - Approach </a:t>
+            </a:r>
+          </a:p>
+        </p:txBody>
+      </p:sp>
+      <p:sp>
+        <p:nvSpPr>
+          <p:cNvPr id="3" name="Content Placeholder 2">
+            <a:extLst>
+              <a:ext uri="{FF2B5EF4-FFF2-40B4-BE49-F238E27FC236}">
+                <a16:creationId xmlns:a16="http://schemas.microsoft.com/office/drawing/2014/main" id="{89565C86-32DF-A074-928D-2764F1413C8F}"/>
+              </a:ext>
+            </a:extLst>
+          </p:cNvPr>
+          <p:cNvSpPr>
+            <a:spLocks noGrp="1"/>
+          </p:cNvSpPr>
+          <p:nvPr>
+            <p:ph idx="1"/>
+          </p:nvPr>
+        </p:nvSpPr>
+        <p:spPr/>
+        <p:txBody>
+          <a:bodyPr/>
+          <a:lstStyle/>
+          <a:p>
+            <a:r>
+              <a:rPr lang="en-US" dirty="0"/>
+              <a:t>Model selection: Multi-Layer Perception (MLP)</a:t>
+            </a:r>
+          </a:p>
+          <a:p>
+            <a:pPr lvl="1"/>
+            <a:r>
+              <a:rPr lang="en-US" dirty="0"/>
+              <a:t>Two hidden layers, 128 and 64 nodes</a:t>
+            </a:r>
+          </a:p>
+          <a:p>
+            <a:pPr lvl="1"/>
+            <a:endParaRPr lang="en-US" dirty="0"/>
+          </a:p>
+        </p:txBody>
+      </p:sp>
+    </p:spTree>
+    <p:extLst>
+      <p:ext uri="{BB962C8B-B14F-4D97-AF65-F5344CB8AC3E}">
+        <p14:creationId xmlns:p14="http://schemas.microsoft.com/office/powerpoint/2010/main" val="1407261242"/>
+      </p:ext>
+    </p:extLst>
+  </p:cSld>
+  <p:clrMapOvr>
+    <a:masterClrMapping/>
+  </p:clrMapOvr>
+</p:sld>
+</file>
+
+<file path=ppt/slides/slide5.xml><?xml version="1.0" encoding="utf-8"?>
+<p:sld xmlns:a="http://schemas.openxmlformats.org/drawingml/2006/main" xmlns:r="http://schemas.openxmlformats.org/officeDocument/2006/relationships" xmlns:p="http://schemas.openxmlformats.org/presentationml/2006/main">
+  <p:cSld>
+    <p:spTree>
+      <p:nvGrpSpPr>
+        <p:cNvPr id="1" name=""/>
+        <p:cNvGrpSpPr/>
+        <p:nvPr/>
+      </p:nvGrpSpPr>
+      <p:grpSpPr>
+        <a:xfrm>
+          <a:off x="0" y="0"/>
+          <a:ext cx="0" cy="0"/>
+          <a:chOff x="0" y="0"/>
+          <a:chExt cx="0" cy="0"/>
+        </a:xfrm>
+      </p:grpSpPr>
+      <p:sp>
+        <p:nvSpPr>
+          <p:cNvPr id="2" name="Title 1">
+            <a:extLst>
+              <a:ext uri="{FF2B5EF4-FFF2-40B4-BE49-F238E27FC236}">
+                <a16:creationId xmlns:a16="http://schemas.microsoft.com/office/drawing/2014/main" id="{C0205E8D-91D7-813C-F768-58A813FB8534}"/>
+              </a:ext>
+            </a:extLst>
+          </p:cNvPr>
+          <p:cNvSpPr>
+            <a:spLocks noGrp="1"/>
+          </p:cNvSpPr>
+          <p:nvPr>
+            <p:ph type="title"/>
+          </p:nvPr>
+        </p:nvSpPr>
+        <p:spPr/>
+        <p:txBody>
+          <a:bodyPr/>
+          <a:lstStyle/>
+          <a:p>
+            <a:r>
+              <a:rPr lang="en-US" dirty="0"/>
+              <a:t>Part 1b - Results</a:t>
+            </a:r>
+          </a:p>
+        </p:txBody>
+      </p:sp>
+      <p:sp>
+        <p:nvSpPr>
+          <p:cNvPr id="3" name="Content Placeholder 2">
+            <a:extLst>
+              <a:ext uri="{FF2B5EF4-FFF2-40B4-BE49-F238E27FC236}">
+                <a16:creationId xmlns:a16="http://schemas.microsoft.com/office/drawing/2014/main" id="{09677AF6-26F1-7D95-A069-4F49FCBFB385}"/>
+              </a:ext>
+            </a:extLst>
+          </p:cNvPr>
+          <p:cNvSpPr>
+            <a:spLocks noGrp="1"/>
+          </p:cNvSpPr>
+          <p:nvPr>
+            <p:ph idx="1"/>
+          </p:nvPr>
+        </p:nvSpPr>
+        <p:spPr/>
+        <p:txBody>
+          <a:bodyPr/>
+          <a:lstStyle/>
+          <a:p>
+            <a:endParaRPr lang="en-US"/>
+          </a:p>
+        </p:txBody>
+      </p:sp>
+    </p:spTree>
+    <p:extLst>
+      <p:ext uri="{BB962C8B-B14F-4D97-AF65-F5344CB8AC3E}">
+        <p14:creationId xmlns:p14="http://schemas.microsoft.com/office/powerpoint/2010/main" val="3470016463"/>
+      </p:ext>
+    </p:extLst>
+  </p:cSld>
+  <p:clrMapOvr>
+    <a:masterClrMapping/>
+  </p:clrMapOvr>
+</p:sld>
+</file>
+
+<file path=ppt/slides/slide6.xml><?xml version="1.0" encoding="utf-8"?>
+<p:sld xmlns:a="http://schemas.openxmlformats.org/drawingml/2006/main" xmlns:r="http://schemas.openxmlformats.org/officeDocument/2006/relationships" xmlns:p="http://schemas.openxmlformats.org/presentationml/2006/main">
+  <p:cSld>
+    <p:spTree>
+      <p:nvGrpSpPr>
+        <p:cNvPr id="1" name=""/>
+        <p:cNvGrpSpPr/>
+        <p:nvPr/>
+      </p:nvGrpSpPr>
+      <p:grpSpPr>
+        <a:xfrm>
+          <a:off x="0" y="0"/>
+          <a:ext cx="0" cy="0"/>
+          <a:chOff x="0" y="0"/>
+          <a:chExt cx="0" cy="0"/>
+        </a:xfrm>
+      </p:grpSpPr>
+      <p:sp>
+        <p:nvSpPr>
+          <p:cNvPr id="2" name="Title 1">
+            <a:extLst>
+              <a:ext uri="{FF2B5EF4-FFF2-40B4-BE49-F238E27FC236}">
+                <a16:creationId xmlns:a16="http://schemas.microsoft.com/office/drawing/2014/main" id="{ED040810-D060-8C4E-8BAA-E64C6833A0AB}"/>
+              </a:ext>
+            </a:extLst>
+          </p:cNvPr>
+          <p:cNvSpPr>
+            <a:spLocks noGrp="1"/>
+          </p:cNvSpPr>
+          <p:nvPr>
+            <p:ph type="title"/>
+          </p:nvPr>
+        </p:nvSpPr>
+        <p:spPr/>
+        <p:txBody>
+          <a:bodyPr/>
+          <a:lstStyle/>
+          <a:p>
+            <a:r>
+              <a:rPr lang="en-US" dirty="0"/>
+              <a:t>Part 1 – Conclusion</a:t>
+            </a:r>
+          </a:p>
+        </p:txBody>
+      </p:sp>
+      <p:sp>
+        <p:nvSpPr>
+          <p:cNvPr id="3" name="Content Placeholder 2">
+            <a:extLst>
+              <a:ext uri="{FF2B5EF4-FFF2-40B4-BE49-F238E27FC236}">
+                <a16:creationId xmlns:a16="http://schemas.microsoft.com/office/drawing/2014/main" id="{1A3E2549-1EBC-B27D-5B4C-56123FFE165B}"/>
+              </a:ext>
+            </a:extLst>
+          </p:cNvPr>
+          <p:cNvSpPr>
+            <a:spLocks noGrp="1"/>
+          </p:cNvSpPr>
+          <p:nvPr>
+            <p:ph idx="1"/>
+          </p:nvPr>
+        </p:nvSpPr>
+        <p:spPr/>
+        <p:txBody>
+          <a:bodyPr/>
+          <a:lstStyle/>
+          <a:p>
+            <a:pPr>
+              <a:lnSpc>
+                <a:spcPct val="200000"/>
+              </a:lnSpc>
+            </a:pPr>
+            <a:r>
+              <a:rPr lang="en-US" dirty="0"/>
+              <a:t>Training time is costly</a:t>
+            </a:r>
+          </a:p>
+          <a:p>
+            <a:pPr>
+              <a:lnSpc>
+                <a:spcPct val="200000"/>
+              </a:lnSpc>
+            </a:pPr>
+            <a:r>
+              <a:rPr lang="en-US" dirty="0"/>
+              <a:t>PCA is powerful</a:t>
+            </a:r>
+          </a:p>
+          <a:p>
+            <a:pPr>
+              <a:lnSpc>
+                <a:spcPct val="200000"/>
+              </a:lnSpc>
+            </a:pPr>
+            <a:r>
+              <a:rPr lang="en-US" dirty="0"/>
+              <a:t>Worth tuning hyperparameters?</a:t>
+            </a:r>
+          </a:p>
+        </p:txBody>
+      </p:sp>
+    </p:spTree>
+    <p:extLst>
+      <p:ext uri="{BB962C8B-B14F-4D97-AF65-F5344CB8AC3E}">
+        <p14:creationId xmlns:p14="http://schemas.microsoft.com/office/powerpoint/2010/main" val="2822892622"/>
+      </p:ext>
+    </p:extLst>
+  </p:cSld>
+  <p:clrMapOvr>
+    <a:masterClrMapping/>
+  </p:clrMapOvr>
+</p:sld>
+</file>
+
+<file path=ppt/slides/slide7.xml><?xml version="1.0" encoding="utf-8"?>
+<p:sld xmlns:a="http://schemas.openxmlformats.org/drawingml/2006/main" xmlns:r="http://schemas.openxmlformats.org/officeDocument/2006/relationships" xmlns:p="http://schemas.openxmlformats.org/presentationml/2006/main">
+  <p:cSld>
+    <p:spTree>
+      <p:nvGrpSpPr>
+        <p:cNvPr id="1" name=""/>
+        <p:cNvGrpSpPr/>
+        <p:nvPr/>
+      </p:nvGrpSpPr>
+      <p:grpSpPr>
+        <a:xfrm>
+          <a:off x="0" y="0"/>
+          <a:ext cx="0" cy="0"/>
+          <a:chOff x="0" y="0"/>
+          <a:chExt cx="0" cy="0"/>
+        </a:xfrm>
+      </p:grpSpPr>
+      <p:sp>
+        <p:nvSpPr>
+          <p:cNvPr id="2" name="Title 1">
+            <a:extLst>
+              <a:ext uri="{FF2B5EF4-FFF2-40B4-BE49-F238E27FC236}">
+                <a16:creationId xmlns:a16="http://schemas.microsoft.com/office/drawing/2014/main" id="{68F4FC0C-A23E-D74B-F1DF-5D461D21668D}"/>
+              </a:ext>
+            </a:extLst>
+          </p:cNvPr>
+          <p:cNvSpPr>
+            <a:spLocks noGrp="1"/>
+          </p:cNvSpPr>
+          <p:nvPr>
+            <p:ph type="title"/>
+          </p:nvPr>
+        </p:nvSpPr>
+        <p:spPr/>
+        <p:txBody>
+          <a:bodyPr/>
+          <a:lstStyle/>
+          <a:p>
+            <a:r>
+              <a:rPr lang="en-US" dirty="0"/>
+              <a:t>Part 2 – Approach</a:t>
+            </a:r>
+          </a:p>
+        </p:txBody>
+      </p:sp>
+      <p:sp>
+        <p:nvSpPr>
+          <p:cNvPr id="3" name="Content Placeholder 2">
+            <a:extLst>
+              <a:ext uri="{FF2B5EF4-FFF2-40B4-BE49-F238E27FC236}">
+                <a16:creationId xmlns:a16="http://schemas.microsoft.com/office/drawing/2014/main" id="{585BBA4F-AC3D-AC68-6162-E0F999A8794B}"/>
+              </a:ext>
+            </a:extLst>
+          </p:cNvPr>
+          <p:cNvSpPr>
+            <a:spLocks noGrp="1"/>
+          </p:cNvSpPr>
+          <p:nvPr>
+            <p:ph idx="1"/>
+          </p:nvPr>
+        </p:nvSpPr>
+        <p:spPr/>
+        <p:txBody>
+          <a:bodyPr>
+            <a:normAutofit fontScale="92500" lnSpcReduction="20000"/>
+          </a:bodyPr>
+          <a:lstStyle/>
+          <a:p>
+            <a:r>
+              <a:rPr lang="en-US" dirty="0"/>
+              <a:t>Model Selection (Traditional): </a:t>
+            </a:r>
+            <a:r>
+              <a:rPr lang="en-US" dirty="0" err="1"/>
+              <a:t>LogReg</a:t>
+            </a:r>
+            <a:endParaRPr lang="en-US" dirty="0"/>
+          </a:p>
+          <a:p>
+            <a:pPr lvl="1"/>
+            <a:r>
+              <a:rPr lang="en-US" dirty="0" err="1"/>
+              <a:t>StratifiedKFold</a:t>
+            </a:r>
+            <a:r>
+              <a:rPr lang="en-US" dirty="0"/>
+              <a:t> CV used to determine best model</a:t>
+            </a:r>
+          </a:p>
+          <a:p>
+            <a:pPr lvl="1"/>
+            <a:r>
+              <a:rPr lang="en-US" dirty="0" err="1"/>
+              <a:t>StandardScalar</a:t>
+            </a:r>
+            <a:r>
+              <a:rPr lang="en-US" dirty="0"/>
+              <a:t> used to normalize data</a:t>
+            </a:r>
+          </a:p>
+          <a:p>
+            <a:pPr lvl="1"/>
+            <a:r>
+              <a:rPr lang="en-US" dirty="0" err="1"/>
+              <a:t>SelectKBest</a:t>
+            </a:r>
+            <a:r>
+              <a:rPr lang="en-US" dirty="0"/>
+              <a:t> used to reduce dimensionality</a:t>
+            </a:r>
+          </a:p>
+          <a:p>
+            <a:pPr lvl="1"/>
+            <a:endParaRPr lang="en-US" dirty="0"/>
+          </a:p>
+          <a:p>
+            <a:r>
+              <a:rPr lang="en-US" dirty="0"/>
+              <a:t>Model Selection (Deep Learning): MLP</a:t>
+            </a:r>
+          </a:p>
+          <a:p>
+            <a:pPr lvl="1"/>
+            <a:r>
+              <a:rPr lang="en-US" dirty="0" err="1"/>
+              <a:t>RepeatedStratifiedKFold</a:t>
+            </a:r>
+            <a:r>
+              <a:rPr lang="en-US" dirty="0"/>
+              <a:t> CV used to determine hyperparameters</a:t>
+            </a:r>
+          </a:p>
+          <a:p>
+            <a:pPr lvl="1"/>
+            <a:r>
+              <a:rPr lang="en-US" dirty="0" err="1"/>
+              <a:t>StandardScalar</a:t>
+            </a:r>
+            <a:r>
+              <a:rPr lang="en-US" dirty="0"/>
+              <a:t> used to normalize data</a:t>
+            </a:r>
+          </a:p>
+          <a:p>
+            <a:pPr lvl="1"/>
+            <a:r>
+              <a:rPr lang="en-US" dirty="0" err="1"/>
+              <a:t>SelectKBest</a:t>
+            </a:r>
+            <a:r>
+              <a:rPr lang="en-US" dirty="0"/>
+              <a:t> used to reduce dimensionality</a:t>
+            </a:r>
+          </a:p>
+          <a:p>
+            <a:pPr lvl="1"/>
+            <a:r>
+              <a:rPr lang="en-US" dirty="0" err="1"/>
+              <a:t>ReLU</a:t>
+            </a:r>
+            <a:r>
+              <a:rPr lang="en-US" dirty="0"/>
+              <a:t> with 0.25 dropout</a:t>
+            </a:r>
+          </a:p>
+          <a:p>
+            <a:pPr lvl="1"/>
+            <a:r>
+              <a:rPr lang="en-US" dirty="0" err="1"/>
+              <a:t>BatchNorm</a:t>
+            </a:r>
+            <a:r>
+              <a:rPr lang="en-US" dirty="0"/>
+              <a:t> used to normalize activations</a:t>
+            </a:r>
+          </a:p>
+          <a:p>
+            <a:pPr lvl="1"/>
+            <a:r>
+              <a:rPr lang="en-US" dirty="0" err="1"/>
+              <a:t>BCEWithLogitsLoss</a:t>
+            </a:r>
+            <a:r>
+              <a:rPr lang="en-US" dirty="0"/>
+              <a:t> used to measure error</a:t>
+            </a:r>
+          </a:p>
+          <a:p>
+            <a:endParaRPr lang="en-US" dirty="0"/>
+          </a:p>
+        </p:txBody>
+      </p:sp>
+    </p:spTree>
+    <p:extLst>
+      <p:ext uri="{BB962C8B-B14F-4D97-AF65-F5344CB8AC3E}">
+        <p14:creationId xmlns:p14="http://schemas.microsoft.com/office/powerpoint/2010/main" val="185969209"/>
+      </p:ext>
+    </p:extLst>
+  </p:cSld>
+  <p:clrMapOvr>
+    <a:masterClrMapping/>
+  </p:clrMapOvr>
+</p:sld>
+</file>
+
+<file path=ppt/slides/slide8.xml><?xml version="1.0" encoding="utf-8"?>
+<p:sld xmlns:a="http://schemas.openxmlformats.org/drawingml/2006/main" xmlns:r="http://schemas.openxmlformats.org/officeDocument/2006/relationships" xmlns:p="http://schemas.openxmlformats.org/presentationml/2006/main">
+  <p:cSld>
+    <p:spTree>
+      <p:nvGrpSpPr>
+        <p:cNvPr id="1" name=""/>
+        <p:cNvGrpSpPr/>
+        <p:nvPr/>
+      </p:nvGrpSpPr>
+      <p:grpSpPr>
+        <a:xfrm>
+          <a:off x="0" y="0"/>
+          <a:ext cx="0" cy="0"/>
+          <a:chOff x="0" y="0"/>
+          <a:chExt cx="0" cy="0"/>
+        </a:xfrm>
+      </p:grpSpPr>
+      <p:sp>
+        <p:nvSpPr>
+          <p:cNvPr id="2" name="Title 1">
+            <a:extLst>
+              <a:ext uri="{FF2B5EF4-FFF2-40B4-BE49-F238E27FC236}">
+                <a16:creationId xmlns:a16="http://schemas.microsoft.com/office/drawing/2014/main" id="{64AD0586-234F-A455-C049-C953A2065E61}"/>
+              </a:ext>
+            </a:extLst>
+          </p:cNvPr>
+          <p:cNvSpPr>
+            <a:spLocks noGrp="1"/>
+          </p:cNvSpPr>
+          <p:nvPr>
+            <p:ph type="title"/>
+          </p:nvPr>
+        </p:nvSpPr>
+        <p:spPr/>
+        <p:txBody>
+          <a:bodyPr/>
+          <a:lstStyle/>
+          <a:p>
+            <a:r>
+              <a:rPr lang="en-US" dirty="0"/>
+              <a:t>Part 2 – Results</a:t>
+            </a:r>
+          </a:p>
+        </p:txBody>
+      </p:sp>
+      <p:sp>
+        <p:nvSpPr>
+          <p:cNvPr id="3" name="Content Placeholder 2">
+            <a:extLst>
+              <a:ext uri="{FF2B5EF4-FFF2-40B4-BE49-F238E27FC236}">
+                <a16:creationId xmlns:a16="http://schemas.microsoft.com/office/drawing/2014/main" id="{561478C8-F244-57BA-FCE1-BB7325332BFE}"/>
+              </a:ext>
+            </a:extLst>
+          </p:cNvPr>
+          <p:cNvSpPr>
+            <a:spLocks noGrp="1"/>
+          </p:cNvSpPr>
+          <p:nvPr>
+            <p:ph idx="1"/>
+          </p:nvPr>
+        </p:nvSpPr>
+        <p:spPr/>
+        <p:txBody>
+          <a:bodyPr/>
+          <a:lstStyle/>
+          <a:p>
+            <a:endParaRPr lang="en-US" dirty="0"/>
+          </a:p>
+        </p:txBody>
+      </p:sp>
+    </p:spTree>
+    <p:extLst>
+      <p:ext uri="{BB962C8B-B14F-4D97-AF65-F5344CB8AC3E}">
+        <p14:creationId xmlns:p14="http://schemas.microsoft.com/office/powerpoint/2010/main" val="373993910"/>
+      </p:ext>
+    </p:extLst>
+  </p:cSld>
+  <p:clrMapOvr>
+    <a:masterClrMapping/>
+  </p:clrMapOvr>
+</p:sld>
+</file>
+
+<file path=ppt/slides/slide9.xml><?xml version="1.0" encoding="utf-8"?>
+<p:sld xmlns:a="http://schemas.openxmlformats.org/drawingml/2006/main" xmlns:r="http://schemas.openxmlformats.org/officeDocument/2006/relationships" xmlns:p="http://schemas.openxmlformats.org/presentationml/2006/main">
+  <p:cSld>
+    <p:spTree>
+      <p:nvGrpSpPr>
+        <p:cNvPr id="1" name=""/>
+        <p:cNvGrpSpPr/>
+        <p:nvPr/>
+      </p:nvGrpSpPr>
+      <p:grpSpPr>
+        <a:xfrm>
+          <a:off x="0" y="0"/>
+          <a:ext cx="0" cy="0"/>
+          <a:chOff x="0" y="0"/>
+          <a:chExt cx="0" cy="0"/>
+        </a:xfrm>
+      </p:grpSpPr>
+      <p:sp>
+        <p:nvSpPr>
+          <p:cNvPr id="2" name="Title 1">
+            <a:extLst>
+              <a:ext uri="{FF2B5EF4-FFF2-40B4-BE49-F238E27FC236}">
+                <a16:creationId xmlns:a16="http://schemas.microsoft.com/office/drawing/2014/main" id="{804B22E2-45CD-80E4-43BD-6E3DC616A6BA}"/>
+              </a:ext>
+            </a:extLst>
+          </p:cNvPr>
+          <p:cNvSpPr>
+            <a:spLocks noGrp="1"/>
+          </p:cNvSpPr>
+          <p:nvPr>
+            <p:ph type="title"/>
+          </p:nvPr>
+        </p:nvSpPr>
+        <p:spPr/>
+        <p:txBody>
+          <a:bodyPr/>
+          <a:lstStyle/>
+          <a:p>
+            <a:r>
+              <a:rPr lang="en-US" dirty="0"/>
+              <a:t>Part </a:t>
+            </a:r>
+            <a:r>
+              <a:rPr lang="en-US"/>
+              <a:t>2 – Conclusion</a:t>
+            </a:r>
+          </a:p>
+        </p:txBody>
+      </p:sp>
+      <p:sp>
+        <p:nvSpPr>
+          <p:cNvPr id="3" name="Content Placeholder 2">
+            <a:extLst>
+              <a:ext uri="{FF2B5EF4-FFF2-40B4-BE49-F238E27FC236}">
+                <a16:creationId xmlns:a16="http://schemas.microsoft.com/office/drawing/2014/main" id="{9A469714-4927-D2FD-DF64-9AC206900752}"/>
+              </a:ext>
+            </a:extLst>
+          </p:cNvPr>
+          <p:cNvSpPr>
+            <a:spLocks noGrp="1"/>
+          </p:cNvSpPr>
+          <p:nvPr>
+            <p:ph idx="1"/>
+          </p:nvPr>
+        </p:nvSpPr>
+        <p:spPr/>
+        <p:txBody>
+          <a:bodyPr/>
+          <a:lstStyle/>
+          <a:p>
+            <a:endParaRPr lang="en-US"/>
+          </a:p>
+        </p:txBody>
+      </p:sp>
+    </p:spTree>
+    <p:extLst>
+      <p:ext uri="{BB962C8B-B14F-4D97-AF65-F5344CB8AC3E}">
+        <p14:creationId xmlns:p14="http://schemas.microsoft.com/office/powerpoint/2010/main" val="1077775097"/>
       </p:ext>
     </p:extLst>
   </p:cSld>

</xml_diff>

<commit_message>
Final edits to slideshow
</commit_message>
<xml_diff>
--- a/Documentation/Final Presentation.pptx
+++ b/Documentation/Final Presentation.pptx
@@ -474,6 +474,190 @@
 </file>
 
 <file path=ppt/notesSlides/notesSlide1.xml><?xml version="1.0" encoding="utf-8"?>
+<p:notes xmlns:a="http://schemas.openxmlformats.org/drawingml/2006/main" xmlns:r="http://schemas.openxmlformats.org/officeDocument/2006/relationships" xmlns:p="http://schemas.openxmlformats.org/presentationml/2006/main">
+  <p:cSld>
+    <p:spTree>
+      <p:nvGrpSpPr>
+        <p:cNvPr id="1" name=""/>
+        <p:cNvGrpSpPr/>
+        <p:nvPr/>
+      </p:nvGrpSpPr>
+      <p:grpSpPr>
+        <a:xfrm>
+          <a:off x="0" y="0"/>
+          <a:ext cx="0" cy="0"/>
+          <a:chOff x="0" y="0"/>
+          <a:chExt cx="0" cy="0"/>
+        </a:xfrm>
+      </p:grpSpPr>
+      <p:sp>
+        <p:nvSpPr>
+          <p:cNvPr id="2" name="Slide Image Placeholder 1"/>
+          <p:cNvSpPr>
+            <a:spLocks noGrp="1" noRot="1" noChangeAspect="1"/>
+          </p:cNvSpPr>
+          <p:nvPr>
+            <p:ph type="sldImg"/>
+          </p:nvPr>
+        </p:nvSpPr>
+        <p:spPr/>
+      </p:sp>
+      <p:sp>
+        <p:nvSpPr>
+          <p:cNvPr id="3" name="Notes Placeholder 2"/>
+          <p:cNvSpPr>
+            <a:spLocks noGrp="1"/>
+          </p:cNvSpPr>
+          <p:nvPr>
+            <p:ph type="body" idx="1"/>
+          </p:nvPr>
+        </p:nvSpPr>
+        <p:spPr/>
+        <p:txBody>
+          <a:bodyPr/>
+          <a:lstStyle/>
+          <a:p>
+            <a:r>
+              <a:rPr lang="en-US" dirty="0"/>
+              <a:t>Accuracy due to perfectly balanced classes</a:t>
+            </a:r>
+          </a:p>
+          <a:p>
+            <a:r>
+              <a:rPr lang="en-US" dirty="0"/>
+              <a:t>PCA kept 95% of variance</a:t>
+            </a:r>
+          </a:p>
+        </p:txBody>
+      </p:sp>
+      <p:sp>
+        <p:nvSpPr>
+          <p:cNvPr id="4" name="Slide Number Placeholder 3"/>
+          <p:cNvSpPr>
+            <a:spLocks noGrp="1"/>
+          </p:cNvSpPr>
+          <p:nvPr>
+            <p:ph type="sldNum" sz="quarter" idx="5"/>
+          </p:nvPr>
+        </p:nvSpPr>
+        <p:spPr/>
+        <p:txBody>
+          <a:bodyPr/>
+          <a:lstStyle/>
+          <a:p>
+            <a:fld id="{3A6D4FA5-9B1B-4DF8-A772-70222F2067D9}" type="slidenum">
+              <a:rPr lang="en-US" smtClean="0"/>
+              <a:t>2</a:t>
+            </a:fld>
+            <a:endParaRPr lang="en-US"/>
+          </a:p>
+        </p:txBody>
+      </p:sp>
+    </p:spTree>
+    <p:extLst>
+      <p:ext uri="{BB962C8B-B14F-4D97-AF65-F5344CB8AC3E}">
+        <p14:creationId xmlns:p14="http://schemas.microsoft.com/office/powerpoint/2010/main" val="2739262936"/>
+      </p:ext>
+    </p:extLst>
+  </p:cSld>
+  <p:clrMapOvr>
+    <a:masterClrMapping/>
+  </p:clrMapOvr>
+</p:notes>
+</file>
+
+<file path=ppt/notesSlides/notesSlide2.xml><?xml version="1.0" encoding="utf-8"?>
+<p:notes xmlns:a="http://schemas.openxmlformats.org/drawingml/2006/main" xmlns:r="http://schemas.openxmlformats.org/officeDocument/2006/relationships" xmlns:p="http://schemas.openxmlformats.org/presentationml/2006/main">
+  <p:cSld>
+    <p:spTree>
+      <p:nvGrpSpPr>
+        <p:cNvPr id="1" name=""/>
+        <p:cNvGrpSpPr/>
+        <p:nvPr/>
+      </p:nvGrpSpPr>
+      <p:grpSpPr>
+        <a:xfrm>
+          <a:off x="0" y="0"/>
+          <a:ext cx="0" cy="0"/>
+          <a:chOff x="0" y="0"/>
+          <a:chExt cx="0" cy="0"/>
+        </a:xfrm>
+      </p:grpSpPr>
+      <p:sp>
+        <p:nvSpPr>
+          <p:cNvPr id="2" name="Slide Image Placeholder 1"/>
+          <p:cNvSpPr>
+            <a:spLocks noGrp="1" noRot="1" noChangeAspect="1"/>
+          </p:cNvSpPr>
+          <p:nvPr>
+            <p:ph type="sldImg"/>
+          </p:nvPr>
+        </p:nvSpPr>
+        <p:spPr/>
+      </p:sp>
+      <p:sp>
+        <p:nvSpPr>
+          <p:cNvPr id="3" name="Notes Placeholder 2"/>
+          <p:cNvSpPr>
+            <a:spLocks noGrp="1"/>
+          </p:cNvSpPr>
+          <p:nvPr>
+            <p:ph type="body" idx="1"/>
+          </p:nvPr>
+        </p:nvSpPr>
+        <p:spPr/>
+        <p:txBody>
+          <a:bodyPr/>
+          <a:lstStyle/>
+          <a:p>
+            <a:r>
+              <a:rPr lang="en-US" dirty="0" err="1"/>
+              <a:t>BatchNorm</a:t>
+            </a:r>
+            <a:r>
+              <a:rPr lang="en-US" dirty="0"/>
+              <a:t> after each layer to normalize activation, stabilizes distribution</a:t>
+            </a:r>
+          </a:p>
+        </p:txBody>
+      </p:sp>
+      <p:sp>
+        <p:nvSpPr>
+          <p:cNvPr id="4" name="Slide Number Placeholder 3"/>
+          <p:cNvSpPr>
+            <a:spLocks noGrp="1"/>
+          </p:cNvSpPr>
+          <p:nvPr>
+            <p:ph type="sldNum" sz="quarter" idx="5"/>
+          </p:nvPr>
+        </p:nvSpPr>
+        <p:spPr/>
+        <p:txBody>
+          <a:bodyPr/>
+          <a:lstStyle/>
+          <a:p>
+            <a:fld id="{3A6D4FA5-9B1B-4DF8-A772-70222F2067D9}" type="slidenum">
+              <a:rPr lang="en-US" smtClean="0"/>
+              <a:t>4</a:t>
+            </a:fld>
+            <a:endParaRPr lang="en-US"/>
+          </a:p>
+        </p:txBody>
+      </p:sp>
+    </p:spTree>
+    <p:extLst>
+      <p:ext uri="{BB962C8B-B14F-4D97-AF65-F5344CB8AC3E}">
+        <p14:creationId xmlns:p14="http://schemas.microsoft.com/office/powerpoint/2010/main" val="588109343"/>
+      </p:ext>
+    </p:extLst>
+  </p:cSld>
+  <p:clrMapOvr>
+    <a:masterClrMapping/>
+  </p:clrMapOvr>
+</p:notes>
+</file>
+
+<file path=ppt/notesSlides/notesSlide3.xml><?xml version="1.0" encoding="utf-8"?>
 <p:notes xmlns:a="http://schemas.openxmlformats.org/drawingml/2006/main" xmlns:r="http://schemas.openxmlformats.org/officeDocument/2006/relationships" xmlns:p="http://schemas.openxmlformats.org/presentationml/2006/main">
   <p:cSld>
     <p:spTree>
@@ -6612,13 +6796,6 @@
               <a:rPr lang="en-US" dirty="0"/>
               <a:t>Performance metric was accuracy over all 5 folds</a:t>
             </a:r>
-          </a:p>
-          <a:p>
-            <a:pPr lvl="3"/>
-            <a:r>
-              <a:rPr lang="en-US" dirty="0"/>
-              <a:t>Perfectly balanced classes</a:t>
-            </a:r>
             <a:endParaRPr lang="en-US" b="1" dirty="0"/>
           </a:p>
           <a:p>
@@ -6633,13 +6810,6 @@
             <a:r>
               <a:rPr lang="en-US" dirty="0"/>
               <a:t>48 dimensions to 31 dimensions</a:t>
-            </a:r>
-          </a:p>
-          <a:p>
-            <a:pPr lvl="2"/>
-            <a:r>
-              <a:rPr lang="en-US" dirty="0"/>
-              <a:t>95% variance threshold</a:t>
             </a:r>
           </a:p>
           <a:p>
@@ -6889,7 +7059,55 @@
           </a:p>
           <a:p>
             <a:pPr lvl="1"/>
+            <a:r>
+              <a:rPr lang="en-US" dirty="0" err="1"/>
+              <a:t>BatchNorm</a:t>
+            </a:r>
+            <a:r>
+              <a:rPr lang="en-US" dirty="0"/>
+              <a:t> after each layer</a:t>
+            </a:r>
+          </a:p>
+          <a:p>
+            <a:pPr lvl="1"/>
+            <a:r>
+              <a:rPr lang="en-US" dirty="0"/>
+              <a:t>Activation function was </a:t>
+            </a:r>
+            <a:r>
+              <a:rPr lang="en-US" dirty="0" err="1"/>
+              <a:t>ReLU</a:t>
+            </a:r>
             <a:endParaRPr lang="en-US" dirty="0"/>
+          </a:p>
+          <a:p>
+            <a:pPr lvl="1"/>
+            <a:r>
+              <a:rPr lang="en-US" dirty="0"/>
+              <a:t>Dropout (0.3)</a:t>
+            </a:r>
+          </a:p>
+          <a:p>
+            <a:pPr lvl="1"/>
+            <a:r>
+              <a:rPr lang="en-US" dirty="0"/>
+              <a:t>Adam used for learning rate</a:t>
+            </a:r>
+          </a:p>
+          <a:p>
+            <a:pPr lvl="1"/>
+            <a:r>
+              <a:rPr lang="en-US" dirty="0"/>
+              <a:t>Performance validated with </a:t>
+            </a:r>
+            <a:r>
+              <a:rPr lang="en-US" dirty="0" err="1"/>
+              <a:t>StratifiedKFold</a:t>
+            </a:r>
+            <a:r>
+              <a:rPr lang="en-US" dirty="0"/>
+              <a:t> (k=5)</a:t>
+            </a:r>
           </a:p>
         </p:txBody>
       </p:sp>
@@ -6972,7 +7190,57 @@
           <a:bodyPr/>
           <a:lstStyle/>
           <a:p>
-            <a:endParaRPr lang="en-US"/>
+            <a:r>
+              <a:rPr lang="en-US" dirty="0"/>
+              <a:t>Five-Fold CV results (80%)</a:t>
+            </a:r>
+          </a:p>
+          <a:p>
+            <a:pPr lvl="1"/>
+            <a:r>
+              <a:rPr lang="en-US" dirty="0"/>
+              <a:t>Accuracy: 0.761</a:t>
+            </a:r>
+          </a:p>
+          <a:p>
+            <a:pPr lvl="1"/>
+            <a:r>
+              <a:rPr lang="en-US" dirty="0"/>
+              <a:t>F1: 0.759</a:t>
+            </a:r>
+          </a:p>
+          <a:p>
+            <a:r>
+              <a:rPr lang="en-US" dirty="0"/>
+              <a:t>Held out 20%</a:t>
+            </a:r>
+          </a:p>
+          <a:p>
+            <a:pPr lvl="1"/>
+            <a:r>
+              <a:rPr lang="en-US" dirty="0"/>
+              <a:t>Accuracy: 0.771</a:t>
+            </a:r>
+          </a:p>
+          <a:p>
+            <a:pPr lvl="1"/>
+            <a:r>
+              <a:rPr lang="en-US" dirty="0"/>
+              <a:t>F1: 0.769</a:t>
+            </a:r>
+          </a:p>
+          <a:p>
+            <a:r>
+              <a:rPr lang="en-US" dirty="0"/>
+              <a:t>Predicted Results:</a:t>
+            </a:r>
+          </a:p>
+          <a:p>
+            <a:pPr lvl="1"/>
+            <a:r>
+              <a:rPr lang="en-US" dirty="0"/>
+              <a:t>Similar to held out set. </a:t>
+            </a:r>
           </a:p>
         </p:txBody>
       </p:sp>

</xml_diff>